<commit_message>
Revise documentation and project deliverables for the Uganda Health MOU. Update the build_dos-uganda_docs.py script to reflect changes in the Statement of Interest, including new objectives and a focus on interoperability. Enhance the Word, PDF, and PowerPoint outputs with updated titles, subtitles, and content to align with the latest project guidelines. Introduce a new Grants URL for reference and ensure all documents maintain consistency with the project's branding and messaging standards.
</commit_message>
<xml_diff>
--- a/applications/dos-uganda/documents/dos-uganda_ppt.pptx
+++ b/applications/dos-uganda/documents/dos-uganda_ppt.pptx
@@ -15,6 +15,7 @@
     <p:sldId id="263" r:id="rId14"/>
     <p:sldId id="264" r:id="rId15"/>
     <p:sldId id="265" r:id="rId16"/>
+    <p:sldId id="266" r:id="rId17"/>
   </p:sldIdLst>
   <p:sldSz cx="12191695" cy="6858000" type="screen4x3"/>
   <p:notesSz cx="6858000" cy="9144000"/>
@@ -3129,8 +3130,8 @@
         </p:nvSpPr>
         <p:spPr>
           <a:xfrm>
-            <a:off x="0" y="3657600"/>
-            <a:ext cx="12191695" cy="3200400"/>
+            <a:off x="0" y="3566160"/>
+            <a:ext cx="12191695" cy="3291840"/>
           </a:xfrm>
           <a:prstGeom prst="rect">
             <a:avLst/>
@@ -3172,8 +3173,8 @@
         </p:nvSpPr>
         <p:spPr>
           <a:xfrm>
-            <a:off x="502920" y="3931920"/>
-            <a:ext cx="10972800" cy="320040"/>
+            <a:off x="502920" y="3840480"/>
+            <a:ext cx="10972800" cy="274320"/>
           </a:xfrm>
           <a:prstGeom prst="rect">
             <a:avLst/>
@@ -3198,13 +3199,13 @@
               </a:spcAft>
             </a:pPr>
             <a:r>
-              <a:rPr sz="1200" b="1" i="0">
+              <a:rPr sz="1100" b="1" i="0">
                 <a:solidFill>
                   <a:srgbClr val="0D6E6E"/>
                 </a:solidFill>
                 <a:latin typeface="Calibri"/>
               </a:rPr>
-              <a:t>U.S.–Uganda Health MOU — Funding Opportunity DFOP0017890</a:t>
+              <a:t>U.S. Department of State / GHSD — Advancing Global Health (DFOP0017890)</a:t>
             </a:r>
           </a:p>
         </p:txBody>
@@ -3217,8 +3218,8 @@
         </p:nvSpPr>
         <p:spPr>
           <a:xfrm>
-            <a:off x="502920" y="4434840"/>
-            <a:ext cx="10972800" cy="640080"/>
+            <a:off x="502920" y="4251960"/>
+            <a:ext cx="10972800" cy="502920"/>
           </a:xfrm>
           <a:prstGeom prst="rect">
             <a:avLst/>
@@ -3243,13 +3244,13 @@
               </a:spcAft>
             </a:pPr>
             <a:r>
-              <a:rPr sz="2200" b="1" i="0">
+              <a:rPr sz="2600" b="1" i="0">
                 <a:solidFill>
                   <a:srgbClr val="FFFFFF"/>
                 </a:solidFill>
                 <a:latin typeface="Calibri"/>
               </a:rPr>
-              <a:t>Statement of Interest — Objective 4 Digital Health Scale-Up</a:t>
+              <a:t>Statement of Interest — Step 1</a:t>
             </a:r>
           </a:p>
         </p:txBody>
@@ -3262,7 +3263,7 @@
         </p:nvSpPr>
         <p:spPr>
           <a:xfrm>
-            <a:off x="502920" y="5074920"/>
+            <a:off x="502920" y="4846320"/>
             <a:ext cx="10972800" cy="320040"/>
           </a:xfrm>
           <a:prstGeom prst="rect">
@@ -3294,7 +3295,7 @@
                 </a:solidFill>
                 <a:latin typeface="Calibri"/>
               </a:rPr>
-              <a:t>FairBanks Community Health Intelligence Platform (FCHIP)</a:t>
+              <a:t>FairBanks Medical Centre  ·  FairBanks Community Reach  ·  FCHIP</a:t>
             </a:r>
           </a:p>
         </p:txBody>
@@ -3307,8 +3308,8 @@
         </p:nvSpPr>
         <p:spPr>
           <a:xfrm>
-            <a:off x="502920" y="5486400"/>
-            <a:ext cx="10972800" cy="320040"/>
+            <a:off x="502920" y="5303520"/>
+            <a:ext cx="10972800" cy="411480"/>
           </a:xfrm>
           <a:prstGeom prst="rect">
             <a:avLst/>
@@ -3339,7 +3340,7 @@
                 </a:solidFill>
                 <a:latin typeface="Calibri"/>
               </a:rPr>
-              <a:t>Community-to-facility intelligence interoperable with eCHIS and DHIS2</a:t>
+              <a:t>Objective 4 — Community-to-facility intelligence interoperable with eCHIS and DHIS2</a:t>
             </a:r>
           </a:p>
         </p:txBody>
@@ -3352,8 +3353,53 @@
         </p:nvSpPr>
         <p:spPr>
           <a:xfrm>
-            <a:off x="502920" y="5989320"/>
-            <a:ext cx="10972800" cy="320040"/>
+            <a:off x="502920" y="5852160"/>
+            <a:ext cx="10972800" cy="274320"/>
+          </a:xfrm>
+          <a:prstGeom prst="rect">
+            <a:avLst/>
+          </a:prstGeom>
+          <a:noFill/>
+        </p:spPr>
+        <p:txBody>
+          <a:bodyPr wrap="square">
+            <a:spAutoFit/>
+          </a:bodyPr>
+          <a:lstStyle/>
+          <a:p>
+            <a:pPr algn="l">
+              <a:lnSpc>
+                <a:spcPct val="115000"/>
+              </a:lnSpc>
+              <a:spcBef>
+                <a:spcPts val="0"/>
+              </a:spcBef>
+              <a:spcAft>
+                <a:spcPts val="200"/>
+              </a:spcAft>
+            </a:pPr>
+            <a:r>
+              <a:rPr sz="1200" b="0" i="0">
+                <a:solidFill>
+                  <a:srgbClr val="FFFFFF"/>
+                </a:solidFill>
+                <a:latin typeface="Calibri"/>
+              </a:rPr>
+              <a:t>Win-win Step 1 Statement of Interest  |  Deadline 31 July 2026, 5:00 PM EDT</a:t>
+            </a:r>
+          </a:p>
+        </p:txBody>
+      </p:sp>
+      <p:sp>
+        <p:nvSpPr>
+          <p:cNvPr id="9" name="TextBox 8"/>
+          <p:cNvSpPr txBox="1"/>
+          <p:nvPr/>
+        </p:nvSpPr>
+        <p:spPr>
+          <a:xfrm>
+            <a:off x="502920" y="6217920"/>
+            <a:ext cx="10972800" cy="274320"/>
           </a:xfrm>
           <a:prstGeom prst="rect">
             <a:avLst/>
@@ -3625,7 +3671,7 @@
                 </a:solidFill>
                 <a:latin typeface="Calibri"/>
               </a:rPr>
-              <a:t>Readiness for Full Proposal</a:t>
+              <a:t>Sustainability &amp; Ownership</a:t>
             </a:r>
           </a:p>
         </p:txBody>
@@ -3651,6 +3697,50 @@
             <a:spAutoFit/>
           </a:bodyPr>
           <a:lstStyle/>
+          <a:p>
+            <a:pPr algn="l">
+              <a:lnSpc>
+                <a:spcPct val="128000"/>
+              </a:lnSpc>
+              <a:spcBef>
+                <a:spcPts val="0"/>
+              </a:spcBef>
+              <a:spcAft>
+                <a:spcPts val="1400"/>
+              </a:spcAft>
+            </a:pPr>
+            <a:r>
+              <a:rPr sz="2600" b="0" i="0">
+                <a:solidFill>
+                  <a:srgbClr val="1E2F38"/>
+                </a:solidFill>
+                <a:latin typeface="Calibri"/>
+              </a:rPr>
+              <a:t>• Core clinic and outreach continue as FairBanks operations - the grant accelerates interoperable intelligence and transfer, not basic organisational survival.</a:t>
+            </a:r>
+          </a:p>
+          <a:p>
+            <a:pPr algn="l">
+              <a:lnSpc>
+                <a:spcPct val="128000"/>
+              </a:lnSpc>
+              <a:spcBef>
+                <a:spcPts val="0"/>
+              </a:spcBef>
+              <a:spcAft>
+                <a:spcPts val="1400"/>
+              </a:spcAft>
+            </a:pPr>
+            <a:r>
+              <a:rPr sz="2600" b="0" i="0">
+                <a:solidFill>
+                  <a:srgbClr val="1E2F38"/>
+                </a:solidFill>
+                <a:latin typeface="Calibri"/>
+              </a:rPr>
+              <a:t>• Diversified sustainability pathways after transfer: facility use, district deployments, NGO programme monitoring, partner APIs, and training packages.</a:t>
+            </a:r>
+          </a:p>
           <a:p>
             <a:pPr algn="l">
               <a:lnSpc>
@@ -3670,7 +3760,7 @@
                 </a:solidFill>
                 <a:latin typeface="Calibri"/>
               </a:rPr>
-              <a:t>Ready to develop a full Objective 4 proposal with partners and MoH-aligned reviewers.</a:t>
+              <a:t>• Local capacity: train Ugandan developers, CHW supervisors, and data stewards; document systems for government handoff.</a:t>
             </a:r>
           </a:p>
         </p:txBody>
@@ -3804,6 +3894,425 @@
                 <a:latin typeface="Calibri"/>
               </a:rPr>
               <a:t>10</a:t>
+            </a:r>
+          </a:p>
+        </p:txBody>
+      </p:sp>
+    </p:spTree>
+  </p:cSld>
+  <p:clrMapOvr>
+    <a:masterClrMapping/>
+  </p:clrMapOvr>
+  <p:timing>
+    <p:tnLst>
+      <p:par>
+        <p:cTn id="1" dur="indefinite" restart="never" nodeType="tmRoot">
+          <p:childTnLst>
+            <p:seq concurrent="true" nextAc="seek">
+              <p:cTn id="2" dur="indefinite" nodeType="mainSeq">
+                <p:childTnLst>
+                  <p:par>
+                    <p:cTn id="9" fill="hold">
+                      <p:stCondLst>
+                        <p:cond delay="0"/>
+                      </p:stCondLst>
+                      <p:childTnLst>
+                        <p:par>
+                          <p:cTn id="3" presetID="10" presetClass="entr" presetSubtype="0" fill="hold" nodeType="withEffect">
+                            <p:stCondLst>
+                              <p:cond delay="0"/>
+                            </p:stCondLst>
+                            <p:childTnLst>
+                              <p:animEffect transition="in" filter="fade">
+                                <p:cBhvr>
+                                  <p:cTn id="4" dur="450"/>
+                                  <p:tgtEl>
+                                    <p:spTgt spid="2"/>
+                                  </p:tgtEl>
+                                </p:cBhvr>
+                              </p:animEffect>
+                            </p:childTnLst>
+                          </p:cTn>
+                        </p:par>
+                        <p:par>
+                          <p:cTn id="5" presetID="10" presetClass="entr" presetSubtype="0" fill="hold" nodeType="withEffect">
+                            <p:stCondLst>
+                              <p:cond delay="200"/>
+                            </p:stCondLst>
+                            <p:childTnLst>
+                              <p:animEffect transition="in" filter="fade">
+                                <p:cBhvr>
+                                  <p:cTn id="6" dur="450"/>
+                                  <p:tgtEl>
+                                    <p:spTgt spid="3"/>
+                                  </p:tgtEl>
+                                </p:cBhvr>
+                              </p:animEffect>
+                            </p:childTnLst>
+                          </p:cTn>
+                        </p:par>
+                        <p:par>
+                          <p:cTn id="7" presetID="10" presetClass="entr" presetSubtype="0" fill="hold" nodeType="withEffect">
+                            <p:stCondLst>
+                              <p:cond delay="200"/>
+                            </p:stCondLst>
+                            <p:childTnLst>
+                              <p:animEffect transition="in" filter="fade">
+                                <p:cBhvr>
+                                  <p:cTn id="8" dur="450"/>
+                                  <p:tgtEl>
+                                    <p:spTgt spid="4"/>
+                                  </p:tgtEl>
+                                </p:cBhvr>
+                              </p:animEffect>
+                            </p:childTnLst>
+                          </p:cTn>
+                        </p:par>
+                      </p:childTnLst>
+                    </p:cTn>
+                  </p:par>
+                </p:childTnLst>
+              </p:cTn>
+              <p:prevCondLst>
+                <p:cond evt="onPrev" delay="0">
+                  <p:tgtEl>
+                    <p:sldTgt/>
+                  </p:tgtEl>
+                </p:cond>
+              </p:prevCondLst>
+              <p:nextCondLst>
+                <p:cond evt="onNext" delay="0">
+                  <p:tgtEl>
+                    <p:sldTgt/>
+                  </p:tgtEl>
+                </p:cond>
+              </p:nextCondLst>
+            </p:seq>
+          </p:childTnLst>
+        </p:cTn>
+      </p:par>
+    </p:tnLst>
+  </p:timing>
+</p:sld>
+</file>
+
+<file path=ppt/slides/slide11.xml><?xml version="1.0" encoding="utf-8"?>
+<p:sld xmlns:a="http://schemas.openxmlformats.org/drawingml/2006/main" xmlns:p="http://schemas.openxmlformats.org/presentationml/2006/main" xmlns:r="http://schemas.openxmlformats.org/officeDocument/2006/relationships">
+  <p:cSld>
+    <p:spTree>
+      <p:nvGrpSpPr>
+        <p:cNvPr id="1" name=""/>
+        <p:cNvGrpSpPr/>
+        <p:nvPr/>
+      </p:nvGrpSpPr>
+      <p:grpSpPr/>
+      <p:sp>
+        <p:nvSpPr>
+          <p:cNvPr id="2" name="Rectangle 1"/>
+          <p:cNvSpPr/>
+          <p:nvPr/>
+        </p:nvSpPr>
+        <p:spPr>
+          <a:xfrm>
+            <a:off x="0" y="0"/>
+            <a:ext cx="12191695" cy="73152"/>
+          </a:xfrm>
+          <a:prstGeom prst="rect">
+            <a:avLst/>
+          </a:prstGeom>
+          <a:solidFill>
+            <a:srgbClr val="0D6E6E"/>
+          </a:solidFill>
+          <a:ln>
+            <a:noFill/>
+          </a:ln>
+        </p:spPr>
+        <p:style>
+          <a:lnRef idx="1">
+            <a:schemeClr val="accent1"/>
+          </a:lnRef>
+          <a:fillRef idx="3">
+            <a:schemeClr val="accent1"/>
+          </a:fillRef>
+          <a:effectRef idx="2">
+            <a:schemeClr val="accent1"/>
+          </a:effectRef>
+          <a:fontRef idx="minor">
+            <a:schemeClr val="lt1"/>
+          </a:fontRef>
+        </p:style>
+        <p:txBody>
+          <a:bodyPr rtlCol="0" anchor="ctr"/>
+          <a:lstStyle/>
+          <a:p>
+            <a:pPr algn="ctr"/>
+          </a:p>
+        </p:txBody>
+      </p:sp>
+      <p:sp>
+        <p:nvSpPr>
+          <p:cNvPr id="3" name="TextBox 2"/>
+          <p:cNvSpPr txBox="1"/>
+          <p:nvPr/>
+        </p:nvSpPr>
+        <p:spPr>
+          <a:xfrm>
+            <a:off x="457200" y="182880"/>
+            <a:ext cx="1097280" cy="457200"/>
+          </a:xfrm>
+          <a:prstGeom prst="rect">
+            <a:avLst/>
+          </a:prstGeom>
+          <a:noFill/>
+        </p:spPr>
+        <p:txBody>
+          <a:bodyPr wrap="square">
+            <a:spAutoFit/>
+          </a:bodyPr>
+          <a:lstStyle/>
+          <a:p>
+            <a:pPr algn="l">
+              <a:lnSpc>
+                <a:spcPct val="115000"/>
+              </a:lnSpc>
+              <a:spcBef>
+                <a:spcPts val="0"/>
+              </a:spcBef>
+              <a:spcAft>
+                <a:spcPts val="200"/>
+              </a:spcAft>
+            </a:pPr>
+            <a:r>
+              <a:rPr sz="2800" b="1" i="0">
+                <a:solidFill>
+                  <a:srgbClr val="C45C26"/>
+                </a:solidFill>
+                <a:latin typeface="Calibri"/>
+              </a:rPr>
+              <a:t>X</a:t>
+            </a:r>
+          </a:p>
+        </p:txBody>
+      </p:sp>
+      <p:sp>
+        <p:nvSpPr>
+          <p:cNvPr id="4" name="TextBox 3"/>
+          <p:cNvSpPr txBox="1"/>
+          <p:nvPr/>
+        </p:nvSpPr>
+        <p:spPr>
+          <a:xfrm>
+            <a:off x="1463040" y="201168"/>
+            <a:ext cx="10058400" cy="502920"/>
+          </a:xfrm>
+          <a:prstGeom prst="rect">
+            <a:avLst/>
+          </a:prstGeom>
+          <a:noFill/>
+        </p:spPr>
+        <p:txBody>
+          <a:bodyPr wrap="square">
+            <a:spAutoFit/>
+          </a:bodyPr>
+          <a:lstStyle/>
+          <a:p>
+            <a:pPr algn="l">
+              <a:lnSpc>
+                <a:spcPct val="115000"/>
+              </a:lnSpc>
+              <a:spcBef>
+                <a:spcPts val="0"/>
+              </a:spcBef>
+              <a:spcAft>
+                <a:spcPts val="200"/>
+              </a:spcAft>
+            </a:pPr>
+            <a:r>
+              <a:rPr sz="2200" b="1" i="0">
+                <a:solidFill>
+                  <a:srgbClr val="0A1F2E"/>
+                </a:solidFill>
+                <a:latin typeface="Calibri"/>
+              </a:rPr>
+              <a:t>Readiness for Full Proposal</a:t>
+            </a:r>
+          </a:p>
+        </p:txBody>
+      </p:sp>
+      <p:sp>
+        <p:nvSpPr>
+          <p:cNvPr id="5" name="TextBox 4"/>
+          <p:cNvSpPr txBox="1"/>
+          <p:nvPr/>
+        </p:nvSpPr>
+        <p:spPr>
+          <a:xfrm>
+            <a:off x="502920" y="1051560"/>
+            <a:ext cx="11155680" cy="5303520"/>
+          </a:xfrm>
+          <a:prstGeom prst="rect">
+            <a:avLst/>
+          </a:prstGeom>
+          <a:noFill/>
+        </p:spPr>
+        <p:txBody>
+          <a:bodyPr wrap="square">
+            <a:spAutoFit/>
+          </a:bodyPr>
+          <a:lstStyle/>
+          <a:p>
+            <a:pPr algn="l">
+              <a:lnSpc>
+                <a:spcPct val="128000"/>
+              </a:lnSpc>
+              <a:spcBef>
+                <a:spcPts val="0"/>
+              </a:spcBef>
+              <a:spcAft>
+                <a:spcPts val="200"/>
+              </a:spcAft>
+            </a:pPr>
+            <a:r>
+              <a:rPr sz="2600" b="0" i="0">
+                <a:solidFill>
+                  <a:srgbClr val="1E2F38"/>
+                </a:solidFill>
+                <a:latin typeface="Calibri"/>
+              </a:rPr>
+              <a:t>This Statement of Interest confirms FairBanks' intent to advance Objective 4 with a community-rooted, interoperable, government-aligned digital health proposal. We seek invitation to Step 2 (full proposal), where we will detail workplans, budgets, M&amp;E, partnership letters, and a clear transition of staffing and recurrent costs toward sustainable Ugandan ownership.</a:t>
+            </a:r>
+          </a:p>
+        </p:txBody>
+      </p:sp>
+      <p:sp>
+        <p:nvSpPr>
+          <p:cNvPr id="6" name="Rectangle 5"/>
+          <p:cNvSpPr/>
+          <p:nvPr/>
+        </p:nvSpPr>
+        <p:spPr>
+          <a:xfrm>
+            <a:off x="0" y="6601968"/>
+            <a:ext cx="12191695" cy="256032"/>
+          </a:xfrm>
+          <a:prstGeom prst="rect">
+            <a:avLst/>
+          </a:prstGeom>
+          <a:solidFill>
+            <a:srgbClr val="1E2F38"/>
+          </a:solidFill>
+          <a:ln>
+            <a:noFill/>
+          </a:ln>
+        </p:spPr>
+        <p:style>
+          <a:lnRef idx="1">
+            <a:schemeClr val="accent1"/>
+          </a:lnRef>
+          <a:fillRef idx="3">
+            <a:schemeClr val="accent1"/>
+          </a:fillRef>
+          <a:effectRef idx="2">
+            <a:schemeClr val="accent1"/>
+          </a:effectRef>
+          <a:fontRef idx="minor">
+            <a:schemeClr val="lt1"/>
+          </a:fontRef>
+        </p:style>
+        <p:txBody>
+          <a:bodyPr rtlCol="0" anchor="ctr"/>
+          <a:lstStyle/>
+          <a:p>
+            <a:pPr algn="ctr"/>
+          </a:p>
+        </p:txBody>
+      </p:sp>
+      <p:sp>
+        <p:nvSpPr>
+          <p:cNvPr id="7" name="TextBox 6"/>
+          <p:cNvSpPr txBox="1"/>
+          <p:nvPr/>
+        </p:nvSpPr>
+        <p:spPr>
+          <a:xfrm>
+            <a:off x="365760" y="6620256"/>
+            <a:ext cx="10058400" cy="201168"/>
+          </a:xfrm>
+          <a:prstGeom prst="rect">
+            <a:avLst/>
+          </a:prstGeom>
+          <a:noFill/>
+        </p:spPr>
+        <p:txBody>
+          <a:bodyPr wrap="square">
+            <a:spAutoFit/>
+          </a:bodyPr>
+          <a:lstStyle/>
+          <a:p>
+            <a:pPr algn="l">
+              <a:lnSpc>
+                <a:spcPct val="115000"/>
+              </a:lnSpc>
+              <a:spcBef>
+                <a:spcPts val="0"/>
+              </a:spcBef>
+              <a:spcAft>
+                <a:spcPts val="200"/>
+              </a:spcAft>
+            </a:pPr>
+            <a:r>
+              <a:rPr sz="900" b="0" i="0">
+                <a:solidFill>
+                  <a:srgbClr val="FFFFFF"/>
+                </a:solidFill>
+                <a:latin typeface="Calibri"/>
+              </a:rPr>
+              <a:t>FairBanks SOI  |  DFOP0017890 Objective 4  |  Your health, our mission.</a:t>
+            </a:r>
+          </a:p>
+        </p:txBody>
+      </p:sp>
+      <p:sp>
+        <p:nvSpPr>
+          <p:cNvPr id="8" name="TextBox 7"/>
+          <p:cNvSpPr txBox="1"/>
+          <p:nvPr/>
+        </p:nvSpPr>
+        <p:spPr>
+          <a:xfrm>
+            <a:off x="11460175" y="6620256"/>
+            <a:ext cx="457200" cy="201168"/>
+          </a:xfrm>
+          <a:prstGeom prst="rect">
+            <a:avLst/>
+          </a:prstGeom>
+          <a:noFill/>
+        </p:spPr>
+        <p:txBody>
+          <a:bodyPr wrap="square">
+            <a:spAutoFit/>
+          </a:bodyPr>
+          <a:lstStyle/>
+          <a:p>
+            <a:pPr algn="r">
+              <a:lnSpc>
+                <a:spcPct val="115000"/>
+              </a:lnSpc>
+              <a:spcBef>
+                <a:spcPts val="0"/>
+              </a:spcBef>
+              <a:spcAft>
+                <a:spcPts val="200"/>
+              </a:spcAft>
+            </a:pPr>
+            <a:r>
+              <a:rPr sz="900" b="0" i="0">
+                <a:solidFill>
+                  <a:srgbClr val="FFFFFF"/>
+                </a:solidFill>
+                <a:latin typeface="Calibri"/>
+              </a:rPr>
+              <a:t>11</a:t>
             </a:r>
           </a:p>
         </p:txBody>
@@ -4044,21 +4553,45 @@
                 </a:solidFill>
                 <a:latin typeface="Calibri"/>
               </a:rPr>
-              <a:t>Statement of Interest</a:t>
-            </a:r>
-          </a:p>
-        </p:txBody>
-      </p:sp>
-      <p:sp>
-        <p:nvSpPr>
-          <p:cNvPr id="5" name="TextBox 4"/>
+              <a:t>The Problem</a:t>
+            </a:r>
+          </a:p>
+        </p:txBody>
+      </p:sp>
+      <p:pic>
+        <p:nvPicPr>
+          <p:cNvPr id="5" name="Picture 4" descr="outreach_outdoor_clinic_opt.jpg"/>
+          <p:cNvPicPr>
+            <a:picLocks noChangeAspect="1"/>
+          </p:cNvPicPr>
+          <p:nvPr/>
+        </p:nvPicPr>
+        <p:blipFill>
+          <a:blip r:embed="rId2"/>
+          <a:stretch>
+            <a:fillRect/>
+          </a:stretch>
+        </p:blipFill>
+        <p:spPr>
+          <a:xfrm>
+            <a:off x="411480" y="1889760"/>
+            <a:ext cx="5303520" cy="3535680"/>
+          </a:xfrm>
+          <a:prstGeom prst="rect">
+            <a:avLst/>
+          </a:prstGeom>
+        </p:spPr>
+      </p:pic>
+      <p:sp>
+        <p:nvSpPr>
+          <p:cNvPr id="6" name="TextBox 5"/>
           <p:cNvSpPr txBox="1"/>
           <p:nvPr/>
         </p:nvSpPr>
         <p:spPr>
           <a:xfrm>
-            <a:off x="502920" y="1051560"/>
-            <a:ext cx="11155680" cy="5303520"/>
+            <a:off x="5943600" y="1051560"/>
+            <a:ext cx="5852160" cy="5120640"/>
           </a:xfrm>
           <a:prstGeom prst="rect">
             <a:avLst/>
@@ -4083,20 +4616,20 @@
               </a:spcAft>
             </a:pPr>
             <a:r>
-              <a:rPr sz="2600" b="0" i="0">
+              <a:rPr sz="2500" b="0" i="0">
                 <a:solidFill>
                   <a:srgbClr val="1E2F38"/>
                 </a:solidFill>
                 <a:latin typeface="Calibri"/>
               </a:rPr>
-              <a:t>FairBanks Medical Centre and FairBanks Community Reach respectfully submit this Statement of Interest under Objective 4: scaling digital health systems in Uganda. We propose to extend and interoperate community-generated health data — captured by Community Health Workers and Village Health Teams — with national platforms (eCHIS, DHIS2, facility EMRs) through FairBanks Community Health Intelligence Platform (FCHIP).</a:t>
-            </a:r>
-          </a:p>
-        </p:txBody>
-      </p:sp>
-      <p:sp>
-        <p:nvSpPr>
-          <p:cNvPr id="6" name="Rectangle 5"/>
+              <a:t>Uganda's five-year health transition (April 2026-December 2030) asks facilities, districts, and communities to keep HIV, TB, malaria, maternal and child health, immunisation, and outbreak services strong while shifting toward government-led, performance-based programming. That shift only works if decision-makers see what is happening at the last mile - not weeks later in paper registers.</a:t>
+            </a:r>
+          </a:p>
+        </p:txBody>
+      </p:sp>
+      <p:sp>
+        <p:nvSpPr>
+          <p:cNvPr id="7" name="Rectangle 6"/>
           <p:cNvSpPr/>
           <p:nvPr/>
         </p:nvSpPr>
@@ -4139,7 +4672,7 @@
       </p:sp>
       <p:sp>
         <p:nvSpPr>
-          <p:cNvPr id="7" name="TextBox 6"/>
+          <p:cNvPr id="8" name="TextBox 7"/>
           <p:cNvSpPr txBox="1"/>
           <p:nvPr/>
         </p:nvSpPr>
@@ -4184,7 +4717,7 @@
       </p:sp>
       <p:sp>
         <p:nvSpPr>
-          <p:cNvPr id="8" name="TextBox 7"/>
+          <p:cNvPr id="9" name="TextBox 8"/>
           <p:cNvSpPr txBox="1"/>
           <p:nvPr/>
         </p:nvSpPr>
@@ -4463,14 +4996,14 @@
                 </a:solidFill>
                 <a:latin typeface="Calibri"/>
               </a:rPr>
-              <a:t>Organizational Capacity</a:t>
+              <a:t>Statement of Interest</a:t>
             </a:r>
           </a:p>
         </p:txBody>
       </p:sp>
       <p:pic>
         <p:nvPicPr>
-          <p:cNvPr id="5" name="Picture 4" descr="facility_exterior_sign_opt.jpg"/>
+          <p:cNvPr id="5" name="Picture 4" descr="data_flow_iso_labeled_opt.jpg"/>
           <p:cNvPicPr>
             <a:picLocks noChangeAspect="1"/>
           </p:cNvPicPr>
@@ -4484,8 +5017,8 @@
         </p:blipFill>
         <p:spPr>
           <a:xfrm>
-            <a:off x="411480" y="1889760"/>
-            <a:ext cx="5303520" cy="3535680"/>
+            <a:off x="411480" y="1890391"/>
+            <a:ext cx="5303520" cy="3534417"/>
           </a:xfrm>
           <a:prstGeom prst="rect">
             <a:avLst/>
@@ -4513,72 +5046,6 @@
             <a:spAutoFit/>
           </a:bodyPr>
           <a:lstStyle/>
-          <a:p>
-            <a:pPr algn="l">
-              <a:lnSpc>
-                <a:spcPct val="128000"/>
-              </a:lnSpc>
-              <a:spcBef>
-                <a:spcPts val="0"/>
-              </a:spcBef>
-              <a:spcAft>
-                <a:spcPts val="1400"/>
-              </a:spcAft>
-            </a:pPr>
-            <a:r>
-              <a:rPr sz="2600" b="0" i="0">
-                <a:solidFill>
-                  <a:srgbClr val="1E2F38"/>
-                </a:solidFill>
-                <a:latin typeface="Calibri"/>
-              </a:rPr>
-              <a:t>• Operating medical centre with pharmacy, diagnostics, and referral pathways</a:t>
-            </a:r>
-          </a:p>
-          <a:p>
-            <a:pPr algn="l">
-              <a:lnSpc>
-                <a:spcPct val="128000"/>
-              </a:lnSpc>
-              <a:spcBef>
-                <a:spcPts val="0"/>
-              </a:spcBef>
-              <a:spcAft>
-                <a:spcPts val="1400"/>
-              </a:spcAft>
-            </a:pPr>
-            <a:r>
-              <a:rPr sz="2600" b="0" i="0">
-                <a:solidFill>
-                  <a:srgbClr val="1E2F38"/>
-                </a:solidFill>
-                <a:latin typeface="Calibri"/>
-              </a:rPr>
-              <a:t>• Community Reach programmes: maternal &amp; child health, Gericare, NCD screening, school health</a:t>
-            </a:r>
-          </a:p>
-          <a:p>
-            <a:pPr algn="l">
-              <a:lnSpc>
-                <a:spcPct val="128000"/>
-              </a:lnSpc>
-              <a:spcBef>
-                <a:spcPts val="0"/>
-              </a:spcBef>
-              <a:spcAft>
-                <a:spcPts val="1400"/>
-              </a:spcAft>
-            </a:pPr>
-            <a:r>
-              <a:rPr sz="2600" b="0" i="0">
-                <a:solidFill>
-                  <a:srgbClr val="1E2F38"/>
-                </a:solidFill>
-                <a:latin typeface="Calibri"/>
-              </a:rPr>
-              <a:t>• Active CHW/VHT networks in Bukoto, Kyebando, Kisaasi, Kamwokya, Kikaaya</a:t>
-            </a:r>
-          </a:p>
           <a:p>
             <a:pPr algn="l">
               <a:lnSpc>
@@ -4592,13 +5059,13 @@
               </a:spcAft>
             </a:pPr>
             <a:r>
-              <a:rPr sz="2600" b="0" i="0">
+              <a:rPr sz="1900" b="0" i="0">
                 <a:solidFill>
                   <a:srgbClr val="1E2F38"/>
                 </a:solidFill>
                 <a:latin typeface="Calibri"/>
               </a:rPr>
-              <a:t>• Digital health records foundation and pharmacy dispensing data already in use</a:t>
+              <a:t>We propose to pilot and then transfer a community-to-facility intelligence layer - the FairBanks Community Health Intelligence Platform (FCHIP) - that captures CHW/VHT household and visit data offline, syncs securely, maps indicators to national reporting elements, and feeds facility and district action. FCHIP is not a parallel silo. It is a bridge that makes Uganda's existing digital stack (eCHIS, DHIS2, facility EMRs, and related national platforms) more complete at community level and more useful for prevention.</a:t>
             </a:r>
           </a:p>
         </p:txBody>
@@ -4972,45 +5439,21 @@
                 </a:solidFill>
                 <a:latin typeface="Calibri"/>
               </a:rPr>
-              <a:t>Alignment with Objective 4</a:t>
-            </a:r>
-          </a:p>
-        </p:txBody>
-      </p:sp>
-      <p:pic>
-        <p:nvPicPr>
-          <p:cNvPr id="5" name="Picture 4" descr="data_flow_iso_labeled_opt.jpg"/>
-          <p:cNvPicPr>
-            <a:picLocks noChangeAspect="1"/>
-          </p:cNvPicPr>
-          <p:nvPr/>
-        </p:nvPicPr>
-        <p:blipFill>
-          <a:blip r:embed="rId2"/>
-          <a:stretch>
-            <a:fillRect/>
-          </a:stretch>
-        </p:blipFill>
-        <p:spPr>
-          <a:xfrm>
-            <a:off x="411480" y="1890391"/>
-            <a:ext cx="5303520" cy="3534417"/>
-          </a:xfrm>
-          <a:prstGeom prst="rect">
-            <a:avLst/>
-          </a:prstGeom>
-        </p:spPr>
-      </p:pic>
-      <p:sp>
-        <p:nvSpPr>
-          <p:cNvPr id="6" name="TextBox 5"/>
+              <a:t>Win-Win Value</a:t>
+            </a:r>
+          </a:p>
+        </p:txBody>
+      </p:sp>
+      <p:sp>
+        <p:nvSpPr>
+          <p:cNvPr id="5" name="TextBox 4"/>
           <p:cNvSpPr txBox="1"/>
           <p:nvPr/>
         </p:nvSpPr>
         <p:spPr>
           <a:xfrm>
-            <a:off x="5943600" y="1051560"/>
-            <a:ext cx="5852160" cy="5120640"/>
+            <a:off x="502920" y="1051560"/>
+            <a:ext cx="11155680" cy="5303520"/>
           </a:xfrm>
           <a:prstGeom prst="rect">
             <a:avLst/>
@@ -5022,6 +5465,72 @@
             <a:spAutoFit/>
           </a:bodyPr>
           <a:lstStyle/>
+          <a:p>
+            <a:pPr algn="l">
+              <a:lnSpc>
+                <a:spcPct val="128000"/>
+              </a:lnSpc>
+              <a:spcBef>
+                <a:spcPts val="0"/>
+              </a:spcBef>
+              <a:spcAft>
+                <a:spcPts val="1400"/>
+              </a:spcAft>
+            </a:pPr>
+            <a:r>
+              <a:rPr sz="2600" b="0" i="0">
+                <a:solidFill>
+                  <a:srgbClr val="1E2F38"/>
+                </a:solidFill>
+                <a:latin typeface="Calibri"/>
+              </a:rPr>
+              <a:t>• Uganda / Ministry of Health: Richer last-mile data into eCHIS and DHIS2; clearer referral closure; documented handoff p...</a:t>
+            </a:r>
+          </a:p>
+          <a:p>
+            <a:pPr algn="l">
+              <a:lnSpc>
+                <a:spcPct val="128000"/>
+              </a:lnSpc>
+              <a:spcBef>
+                <a:spcPts val="0"/>
+              </a:spcBef>
+              <a:spcAft>
+                <a:spcPts val="1400"/>
+              </a:spcAft>
+            </a:pPr>
+            <a:r>
+              <a:rPr sz="2600" b="0" i="0">
+                <a:solidFill>
+                  <a:srgbClr val="1E2F38"/>
+                </a:solidFill>
+                <a:latin typeface="Calibri"/>
+              </a:rPr>
+              <a:t>• U.S. Department of State / GHSD: A Ugandan implementer with a live clinic and community network that protects essential ser...</a:t>
+            </a:r>
+          </a:p>
+          <a:p>
+            <a:pPr algn="l">
+              <a:lnSpc>
+                <a:spcPct val="128000"/>
+              </a:lnSpc>
+              <a:spcBef>
+                <a:spcPts val="0"/>
+              </a:spcBef>
+              <a:spcAft>
+                <a:spcPts val="1400"/>
+              </a:spcAft>
+            </a:pPr>
+            <a:r>
+              <a:rPr sz="2600" b="0" i="0">
+                <a:solidFill>
+                  <a:srgbClr val="1E2F38"/>
+                </a:solidFill>
+                <a:latin typeface="Calibri"/>
+              </a:rPr>
+              <a:t>• Districts &amp; facilities: Dashboards for outreach targeting, referral follow-up, and programme monitoring; GIS hotsp...</a:t>
+            </a:r>
+          </a:p>
           <a:p>
             <a:pPr algn="l">
               <a:lnSpc>
@@ -5041,14 +5550,14 @@
                 </a:solidFill>
                 <a:latin typeface="Calibri"/>
               </a:rPr>
-              <a:t>FCHIP extends last-mile capture and feeds structured community data upstream</a:t>
-            </a:r>
-          </a:p>
-        </p:txBody>
-      </p:sp>
-      <p:sp>
-        <p:nvSpPr>
-          <p:cNvPr id="7" name="Rectangle 6"/>
+              <a:t>• Communities &amp; CHWs/VHTs: Simple offline tools, faster support from the medical centre, and care that reaches mother...</a:t>
+            </a:r>
+          </a:p>
+        </p:txBody>
+      </p:sp>
+      <p:sp>
+        <p:nvSpPr>
+          <p:cNvPr id="6" name="Rectangle 5"/>
           <p:cNvSpPr/>
           <p:nvPr/>
         </p:nvSpPr>
@@ -5091,7 +5600,7 @@
       </p:sp>
       <p:sp>
         <p:nvSpPr>
-          <p:cNvPr id="8" name="TextBox 7"/>
+          <p:cNvPr id="7" name="TextBox 6"/>
           <p:cNvSpPr txBox="1"/>
           <p:nvPr/>
         </p:nvSpPr>
@@ -5136,7 +5645,7 @@
       </p:sp>
       <p:sp>
         <p:nvSpPr>
-          <p:cNvPr id="9" name="TextBox 8"/>
+          <p:cNvPr id="8" name="TextBox 7"/>
           <p:cNvSpPr txBox="1"/>
           <p:nvPr/>
         </p:nvSpPr>
@@ -5415,7 +5924,7 @@
                 </a:solidFill>
                 <a:latin typeface="Calibri"/>
               </a:rPr>
-              <a:t>Proposed Digital Health Activity</a:t>
+              <a:t>Proposed Objectives</a:t>
             </a:r>
           </a:p>
         </p:txBody>
@@ -5474,17 +5983,17 @@
                 <a:spcPts val="0"/>
               </a:spcBef>
               <a:spcAft>
-                <a:spcPts val="1300"/>
+                <a:spcPts val="1100"/>
               </a:spcAft>
             </a:pPr>
             <a:r>
-              <a:rPr sz="2500" b="0" i="0">
+              <a:rPr sz="2000" b="0" i="0">
                 <a:solidFill>
                   <a:srgbClr val="1E2F38"/>
                 </a:solidFill>
                 <a:latin typeface="Calibri"/>
               </a:rPr>
-              <a:t>• Deploy offline-capable CHW capture aligned with eCHIS household and visit concepts</a:t>
+              <a:t>• O1. Deploy offline-capable CHW/VHT capture aligned with eCHIS household and visit concepts across FairBanks Co...</a:t>
             </a:r>
           </a:p>
           <a:p>
@@ -5496,17 +6005,17 @@
                 <a:spcPts val="0"/>
               </a:spcBef>
               <a:spcAft>
-                <a:spcPts val="1300"/>
+                <a:spcPts val="1100"/>
               </a:spcAft>
             </a:pPr>
             <a:r>
-              <a:rPr sz="2500" b="0" i="0">
+              <a:rPr sz="2000" b="0" i="0">
                 <a:solidFill>
                   <a:srgbClr val="1E2F38"/>
                 </a:solidFill>
                 <a:latin typeface="Calibri"/>
               </a:rPr>
-              <a:t>• Build secure sync pipeline with role-based access for CHWs, facilities, and district viewers</a:t>
+              <a:t>• O2. Establish a secure sync and role-based access pipeline linking community records to FairBanks Medical Cent...</a:t>
             </a:r>
           </a:p>
           <a:p>
@@ -5518,17 +6027,17 @@
                 <a:spcPts val="0"/>
               </a:spcBef>
               <a:spcAft>
-                <a:spcPts val="1300"/>
+                <a:spcPts val="1100"/>
               </a:spcAft>
             </a:pPr>
             <a:r>
-              <a:rPr sz="2500" b="0" i="0">
+              <a:rPr sz="2000" b="0" i="0">
                 <a:solidFill>
                   <a:srgbClr val="1E2F38"/>
                 </a:solidFill>
                 <a:latin typeface="Calibri"/>
               </a:rPr>
-              <a:t>• Map community indicators to DHIS2 reporting elements for aggregate submission</a:t>
+              <a:t>• O3. Map community indicators to DHIS2 reporting elements and demonstrate aggregate submission pathways for MNC...</a:t>
             </a:r>
           </a:p>
           <a:p>
@@ -5544,13 +6053,13 @@
               </a:spcAft>
             </a:pPr>
             <a:r>
-              <a:rPr sz="2500" b="0" i="0">
+              <a:rPr sz="2000" b="0" i="0">
                 <a:solidFill>
                   <a:srgbClr val="1E2F38"/>
                 </a:solidFill>
                 <a:latin typeface="Calibri"/>
               </a:rPr>
-              <a:t>• Provide facility dashboards for referrals, alerts, and programme monitoring</a:t>
+              <a:t>• O4. Deliver facility and programme dashboards plus GIS hotspot views that trigger outreach, referrals, and sup...</a:t>
             </a:r>
           </a:p>
         </p:txBody>
@@ -5924,7 +6433,7 @@
                 </a:solidFill>
                 <a:latin typeface="Calibri"/>
               </a:rPr>
-              <a:t>Interoperability Approach</a:t>
+              <a:t>Project Approach</a:t>
             </a:r>
           </a:p>
         </p:txBody>
@@ -5993,7 +6502,7 @@
                 </a:solidFill>
                 <a:latin typeface="Calibri"/>
               </a:rPr>
-              <a:t>eCHIS household capture → DHIS2 aggregates → facility EMR referrals</a:t>
+              <a:t>Cascade-rooted capture → secure sync → eCHIS/DHIS2/EMR interoperability → dashboards &amp; GIS → MoH-aligned transfer package.</a:t>
             </a:r>
           </a:p>
         </p:txBody>
@@ -6367,14 +6876,14 @@
                 </a:solidFill>
                 <a:latin typeface="Calibri"/>
               </a:rPr>
-              <a:t>Geographic Focus</a:t>
+              <a:t>Expected Outcomes</a:t>
             </a:r>
           </a:p>
         </p:txBody>
       </p:sp>
       <p:pic>
         <p:nvPicPr>
-          <p:cNvPr id="5" name="Picture 4" descr="outreach_outdoor_clinic_opt.jpg"/>
+          <p:cNvPr id="5" name="Picture 4" descr="gis_hotspots_opt.jpg"/>
           <p:cNvPicPr>
             <a:picLocks noChangeAspect="1"/>
           </p:cNvPicPr>
@@ -6388,8 +6897,8 @@
         </p:blipFill>
         <p:spPr>
           <a:xfrm>
-            <a:off x="411480" y="1889760"/>
-            <a:ext cx="5303520" cy="3535680"/>
+            <a:off x="411480" y="1890391"/>
+            <a:ext cx="5303520" cy="3534417"/>
           </a:xfrm>
           <a:prstGeom prst="rect">
             <a:avLst/>
@@ -6417,6 +6926,72 @@
             <a:spAutoFit/>
           </a:bodyPr>
           <a:lstStyle/>
+          <a:p>
+            <a:pPr algn="l">
+              <a:lnSpc>
+                <a:spcPct val="128000"/>
+              </a:lnSpc>
+              <a:spcBef>
+                <a:spcPts val="0"/>
+              </a:spcBef>
+              <a:spcAft>
+                <a:spcPts val="1100"/>
+              </a:spcAft>
+            </a:pPr>
+            <a:r>
+              <a:rPr sz="2000" b="0" i="0">
+                <a:solidFill>
+                  <a:srgbClr val="1E2F38"/>
+                </a:solidFill>
+                <a:latin typeface="Calibri"/>
+              </a:rPr>
+              <a:t>• Digital completeness — Increase structured community visit capture flowing into facility and aggregate </a:t>
+            </a:r>
+          </a:p>
+          <a:p>
+            <a:pPr algn="l">
+              <a:lnSpc>
+                <a:spcPct val="128000"/>
+              </a:lnSpc>
+              <a:spcBef>
+                <a:spcPts val="0"/>
+              </a:spcBef>
+              <a:spcAft>
+                <a:spcPts val="1100"/>
+              </a:spcAft>
+            </a:pPr>
+            <a:r>
+              <a:rPr sz="2000" b="0" i="0">
+                <a:solidFill>
+                  <a:srgbClr val="1E2F38"/>
+                </a:solidFill>
+                <a:latin typeface="Calibri"/>
+              </a:rPr>
+              <a:t>• Interoperability proof — Working mappings and demo exports for eCHIS-aligned records and DHIS2 aggregates</a:t>
+            </a:r>
+          </a:p>
+          <a:p>
+            <a:pPr algn="l">
+              <a:lnSpc>
+                <a:spcPct val="128000"/>
+              </a:lnSpc>
+              <a:spcBef>
+                <a:spcPts val="0"/>
+              </a:spcBef>
+              <a:spcAft>
+                <a:spcPts val="1100"/>
+              </a:spcAft>
+            </a:pPr>
+            <a:r>
+              <a:rPr sz="2000" b="0" i="0">
+                <a:solidFill>
+                  <a:srgbClr val="1E2F38"/>
+                </a:solidFill>
+                <a:latin typeface="Calibri"/>
+              </a:rPr>
+              <a:t>• Service continuity signals — Earlier alerts for missed ANC, immunisation gaps, fever clusters, and referral d</a:t>
+            </a:r>
+          </a:p>
           <a:p>
             <a:pPr algn="l">
               <a:lnSpc>
@@ -6430,13 +7005,13 @@
               </a:spcAft>
             </a:pPr>
             <a:r>
-              <a:rPr sz="2600" b="0" i="0">
+              <a:rPr sz="2000" b="0" i="0">
                 <a:solidFill>
                   <a:srgbClr val="1E2F38"/>
                 </a:solidFill>
                 <a:latin typeface="Calibri"/>
               </a:rPr>
-              <a:t>Primary pilot: FairBanks catchment — Kampala-area communities with live CHW operations</a:t>
+              <a:t>• Accountability — Role-based audit trails, data-quality checks, and programme dashboards usable fo</a:t>
             </a:r>
           </a:p>
         </p:txBody>
@@ -6810,14 +7385,14 @@
                 </a:solidFill>
                 <a:latin typeface="Calibri"/>
               </a:rPr>
-              <a:t>Sustainability &amp; Local Ownership</a:t>
+              <a:t>Organizational Capacity</a:t>
             </a:r>
           </a:p>
         </p:txBody>
       </p:sp>
       <p:pic>
         <p:nvPicPr>
-          <p:cNvPr id="5" name="Picture 4" descr="pharmacy_staff_laptop_01_opt.jpg"/>
+          <p:cNvPr id="5" name="Picture 4" descr="facility_exterior_sign_opt.jpg"/>
           <p:cNvPicPr>
             <a:picLocks noChangeAspect="1"/>
           </p:cNvPicPr>
@@ -6869,17 +7444,17 @@
                 <a:spcPts val="0"/>
               </a:spcBef>
               <a:spcAft>
-                <a:spcPts val="1400"/>
+                <a:spcPts val="1000"/>
               </a:spcAft>
             </a:pPr>
             <a:r>
-              <a:rPr sz="2600" b="0" i="0">
+              <a:rPr sz="1700" b="0" i="0">
                 <a:solidFill>
                   <a:srgbClr val="1E2F38"/>
                 </a:solidFill>
                 <a:latin typeface="Calibri"/>
               </a:rPr>
-              <a:t>• FairBanks operates the medical centre and outreach without grant dependency for core services</a:t>
+              <a:t>• Ugandan social enterprise with a functioning medical centre - clinical care, diagnostics, pharmacy, and referral pathways already in daily use.</a:t>
             </a:r>
           </a:p>
           <a:p>
@@ -6891,17 +7466,39 @@
                 <a:spcPts val="0"/>
               </a:spcBef>
               <a:spcAft>
-                <a:spcPts val="1400"/>
+                <a:spcPts val="1000"/>
               </a:spcAft>
             </a:pPr>
             <a:r>
-              <a:rPr sz="2600" b="0" i="0">
+              <a:rPr sz="1700" b="0" i="0">
                 <a:solidFill>
                   <a:srgbClr val="1E2F38"/>
                 </a:solidFill>
                 <a:latin typeface="Calibri"/>
               </a:rPr>
-              <a:t>• Revenue pathways: clinic subscriptions, district deployments, NGO programme monitoring, partner APIs</a:t>
+              <a:t>• Active FairBanks Community Reach programmes: maternal and child health, Gericare, chronic disease screening, school and corporate health outreach.</a:t>
+            </a:r>
+          </a:p>
+          <a:p>
+            <a:pPr algn="l">
+              <a:lnSpc>
+                <a:spcPct val="128000"/>
+              </a:lnSpc>
+              <a:spcBef>
+                <a:spcPts val="0"/>
+              </a:spcBef>
+              <a:spcAft>
+                <a:spcPts val="1000"/>
+              </a:spcAft>
+            </a:pPr>
+            <a:r>
+              <a:rPr sz="1700" b="0" i="0">
+                <a:solidFill>
+                  <a:srgbClr val="1E2F38"/>
+                </a:solidFill>
+                <a:latin typeface="Calibri"/>
+              </a:rPr>
+              <a:t>• Established CHW/VHT relationships in Kampala-area communities named above - real users, not a greenfield pilot.</a:t>
             </a:r>
           </a:p>
           <a:p>
@@ -6917,13 +7514,13 @@
               </a:spcAft>
             </a:pPr>
             <a:r>
-              <a:rPr sz="2600" b="0" i="0">
+              <a:rPr sz="1700" b="0" i="0">
                 <a:solidFill>
                   <a:srgbClr val="1E2F38"/>
                 </a:solidFill>
                 <a:latin typeface="Calibri"/>
               </a:rPr>
-              <a:t>• Local capacity: train Ugandan developers and data stewards; document systems for MoH handoff</a:t>
+              <a:t>• Digital health records foundation and pharmacy dispensing data already supporting facility operations.</a:t>
             </a:r>
           </a:p>
         </p:txBody>
@@ -7297,14 +7894,14 @@
                 </a:solidFill>
                 <a:latin typeface="Calibri"/>
               </a:rPr>
-              <a:t>Partnership Landscape</a:t>
+              <a:t>Interoperability</a:t>
             </a:r>
           </a:p>
         </p:txBody>
       </p:sp>
       <p:pic>
         <p:nvPicPr>
-          <p:cNvPr id="5" name="Picture 4" descr="gis_hotspots_opt.jpg"/>
+          <p:cNvPr id="5" name="Picture 4" descr="pharmacy_staff_laptop_01_opt.jpg"/>
           <p:cNvPicPr>
             <a:picLocks noChangeAspect="1"/>
           </p:cNvPicPr>
@@ -7318,8 +7915,8 @@
         </p:blipFill>
         <p:spPr>
           <a:xfrm>
-            <a:off x="411480" y="1890391"/>
-            <a:ext cx="5303520" cy="3534417"/>
+            <a:off x="411480" y="1889760"/>
+            <a:ext cx="5303520" cy="3535680"/>
           </a:xfrm>
           <a:prstGeom prst="rect">
             <a:avLst/>
@@ -7347,72 +7944,6 @@
             <a:spAutoFit/>
           </a:bodyPr>
           <a:lstStyle/>
-          <a:p>
-            <a:pPr algn="l">
-              <a:lnSpc>
-                <a:spcPct val="128000"/>
-              </a:lnSpc>
-              <a:spcBef>
-                <a:spcPts val="0"/>
-              </a:spcBef>
-              <a:spcAft>
-                <a:spcPts val="1400"/>
-              </a:spcAft>
-            </a:pPr>
-            <a:r>
-              <a:rPr sz="2600" b="0" i="0">
-                <a:solidFill>
-                  <a:srgbClr val="1E2F38"/>
-                </a:solidFill>
-                <a:latin typeface="Calibri"/>
-              </a:rPr>
-              <a:t>• Ministry of Health community health strategy alignment</a:t>
-            </a:r>
-          </a:p>
-          <a:p>
-            <a:pPr algn="l">
-              <a:lnSpc>
-                <a:spcPct val="128000"/>
-              </a:lnSpc>
-              <a:spcBef>
-                <a:spcPts val="0"/>
-              </a:spcBef>
-              <a:spcAft>
-                <a:spcPts val="1400"/>
-              </a:spcAft>
-            </a:pPr>
-            <a:r>
-              <a:rPr sz="2600" b="0" i="0">
-                <a:solidFill>
-                  <a:srgbClr val="1E2F38"/>
-                </a:solidFill>
-                <a:latin typeface="Calibri"/>
-              </a:rPr>
-              <a:t>• District health teams for aggregate reporting validation</a:t>
-            </a:r>
-          </a:p>
-          <a:p>
-            <a:pPr algn="l">
-              <a:lnSpc>
-                <a:spcPct val="128000"/>
-              </a:lnSpc>
-              <a:spcBef>
-                <a:spcPts val="0"/>
-              </a:spcBef>
-              <a:spcAft>
-                <a:spcPts val="1400"/>
-              </a:spcAft>
-            </a:pPr>
-            <a:r>
-              <a:rPr sz="2600" b="0" i="0">
-                <a:solidFill>
-                  <a:srgbClr val="1E2F38"/>
-                </a:solidFill>
-                <a:latin typeface="Calibri"/>
-              </a:rPr>
-              <a:t>• Academic partners for evaluation and interoperability testing</a:t>
-            </a:r>
-          </a:p>
           <a:p>
             <a:pPr algn="l">
               <a:lnSpc>
@@ -7432,7 +7963,7 @@
                 </a:solidFill>
                 <a:latin typeface="Calibri"/>
               </a:rPr>
-              <a:t>• NGOs and CBOs already working with FairBanks outreach programmes</a:t>
+              <a:t>eCHIS household capture → DHIS2 aggregates → facility EMR referrals → national warehouse readiness. Bridge layer — not a replacement silo.</a:t>
             </a:r>
           </a:p>
         </p:txBody>

</xml_diff>

<commit_message>
Revise build_dos-uganda_docs.py and associated documents to reflect updates in the Statement of Interest for the Uganda Health System MOU (DFOP0017890). Change "Step 1" to "Phase 1" in titles and subtitles, enhance project details including the proposed project title and organization name, and update narrative content to align with new objectives focused on interoperability and government ownership. Ensure consistency across Word, PDF, and PowerPoint formats while maintaining compliance with project guidelines.
</commit_message>
<xml_diff>
--- a/applications/dos-uganda/documents/dos-uganda_ppt.pptx
+++ b/applications/dos-uganda/documents/dos-uganda_ppt.pptx
@@ -3250,7 +3250,7 @@
                 </a:solidFill>
                 <a:latin typeface="Calibri"/>
               </a:rPr>
-              <a:t>Statement of Interest — Step 1</a:t>
+              <a:t>Statement of Interest — Phase 1</a:t>
             </a:r>
           </a:p>
         </p:txBody>
@@ -3340,7 +3340,7 @@
                 </a:solidFill>
                 <a:latin typeface="Calibri"/>
               </a:rPr>
-              <a:t>Objective 4 — Community-to-facility intelligence interoperable with eCHIS and DHIS2</a:t>
+              <a:t>Objective 4 — Last-mile bridge into eCHIS, EMR, DHIS2/eIDSR, and NDHA</a:t>
             </a:r>
           </a:p>
         </p:txBody>
@@ -3385,7 +3385,7 @@
                 </a:solidFill>
                 <a:latin typeface="Calibri"/>
               </a:rPr>
-              <a:t>Win-win Step 1 Statement of Interest  |  Deadline 31 July 2026, 5:00 PM EDT</a:t>
+              <a:t>Win-win Phase 1 SOI  |  $1,850,000  |  36 months  |  Due 31 July 2026</a:t>
             </a:r>
           </a:p>
         </p:txBody>
@@ -3716,7 +3716,7 @@
                 </a:solidFill>
                 <a:latin typeface="Calibri"/>
               </a:rPr>
-              <a:t>• Core clinic and outreach continue as FairBanks operations - the grant accelerates interoperable intelligence and transfer, not basic organisational survival.</a:t>
+              <a:t>Documented transition of staffing and recurrent costs toward GOU ownership by project close.</a:t>
             </a:r>
           </a:p>
           <a:p>
@@ -3738,7 +3738,7 @@
                 </a:solidFill>
                 <a:latin typeface="Calibri"/>
               </a:rPr>
-              <a:t>• Diversified sustainability pathways after transfer: facility use, district deployments, NGO programme monitoring, partner APIs, and training packages.</a:t>
+              <a:t>Train Ugandan developers, CHW supervisors, and data stewards.</a:t>
             </a:r>
           </a:p>
           <a:p>
@@ -3760,7 +3760,7 @@
                 </a:solidFill>
                 <a:latin typeface="Calibri"/>
               </a:rPr>
-              <a:t>• Local capacity: train Ugandan developers, CHW supervisors, and data stewards; document systems for government handoff.</a:t>
+              <a:t>Clinic and outreach continue as FairBanks operations — the grant accelerates interoperable intelligence and transfer.</a:t>
             </a:r>
           </a:p>
         </p:txBody>
@@ -4134,7 +4134,7 @@
                 </a:solidFill>
                 <a:latin typeface="Calibri"/>
               </a:rPr>
-              <a:t>Readiness for Full Proposal</a:t>
+              <a:t>Readiness for Phase 2</a:t>
             </a:r>
           </a:p>
         </p:txBody>
@@ -4179,7 +4179,7 @@
                 </a:solidFill>
                 <a:latin typeface="Calibri"/>
               </a:rPr>
-              <a:t>This Statement of Interest confirms FairBanks' intent to advance Objective 4 with a community-rooted, interoperable, government-aligned digital health proposal. We seek invitation to Step 2 (full proposal), where we will detail workplans, budgets, M&amp;E, partnership letters, and a clear transition of staffing and recurrent costs toward sustainable Ugandan ownership.</a:t>
+              <a:t>This Statement of Interest confirms FairBanks' intent to advance Track 2, Objective 4 with a community-rooted, interoperable, government-aligned digital health proposal. We seek invitation to Phase 2 (full proposal) and/or consultative program design, where we will detail workplans, budgets, M&amp;E, partnership letters, and a clear transition of staffing and recurrent costs toward sustainable Ugandan ownership.</a:t>
             </a:r>
           </a:p>
         </p:txBody>
@@ -4612,17 +4612,39 @@
                 <a:spcPts val="0"/>
               </a:spcBef>
               <a:spcAft>
+                <a:spcPts val="1000"/>
+              </a:spcAft>
+            </a:pPr>
+            <a:r>
+              <a:rPr sz="1500" b="0" i="0">
+                <a:solidFill>
+                  <a:srgbClr val="1E2F38"/>
+                </a:solidFill>
+                <a:latin typeface="Calibri"/>
+              </a:rPr>
+              <a:t>Uganda's five-year health transition (April 2026-December 2030) asks facilities, districts, and communities to keep HIV, TB, malaria, maternal and child health, immunisation, and outbreak services strong while shifting toward government-led, performance-based programming. That shift only works if decision-makers see what is happening at the last mile - not weeks later in paper registers.</a:t>
+            </a:r>
+          </a:p>
+          <a:p>
+            <a:pPr algn="l">
+              <a:lnSpc>
+                <a:spcPct val="128000"/>
+              </a:lnSpc>
+              <a:spcBef>
+                <a:spcPts val="0"/>
+              </a:spcBef>
+              <a:spcAft>
                 <a:spcPts val="200"/>
               </a:spcAft>
             </a:pPr>
             <a:r>
-              <a:rPr sz="2500" b="0" i="0">
+              <a:rPr sz="1500" b="0" i="0">
                 <a:solidFill>
                   <a:srgbClr val="1E2F38"/>
                 </a:solidFill>
                 <a:latin typeface="Calibri"/>
               </a:rPr>
-              <a:t>Uganda's five-year health transition (April 2026-December 2030) asks facilities, districts, and communities to keep HIV, TB, malaria, maternal and child health, immunisation, and outbreak services strong while shifting toward government-led, performance-based programming. That shift only works if decision-makers see what is happening at the last mile - not weeks later in paper registers.</a:t>
+              <a:t>Community Health Workers and Village Health Teams already walk households and refer patients. Too often their work never reaches eCHIS, facility EMRs, DHIS2/eIDSR, or the National Data Warehouse in a usable form. National digital systems then miss early fever clusters, missed antenatal visits, immunisation gaps, and stock pressure. The result is reactive care, weak accountability, and higher risk that transition gains reverse.</a:t>
             </a:r>
           </a:p>
         </p:txBody>
@@ -5059,13 +5081,13 @@
               </a:spcAft>
             </a:pPr>
             <a:r>
-              <a:rPr sz="1900" b="0" i="0">
+              <a:rPr sz="2000" b="0" i="0">
                 <a:solidFill>
                   <a:srgbClr val="1E2F38"/>
                 </a:solidFill>
                 <a:latin typeface="Calibri"/>
               </a:rPr>
-              <a:t>We propose to pilot and then transfer a community-to-facility intelligence layer - the FairBanks Community Health Intelligence Platform (FCHIP) - that captures CHW/VHT household and visit data offline, syncs securely, maps indicators to national reporting elements, and feeds facility and district action. FCHIP is not a parallel silo. It is a bridge that makes Uganda's existing digital stack (eCHIS, DHIS2, facility EMRs, and related national platforms) more complete at community level and more useful for prevention.</a:t>
+              <a:t>We propose to pilot and then transfer a community-to-facility intelligence layer - the FairBanks Community Health Intelligence Platform (FCHIP) - that captures CHW/VHT household and visit data offline, syncs securely, maps indicators to national reporting elements, and feeds facility and district action. FCHIP is not a parallel national system. It is a bridge that makes Uganda's existing digital stack more complete at community level and more useful for prevention.</a:t>
             </a:r>
           </a:p>
         </p:txBody>
@@ -5474,17 +5496,17 @@
                 <a:spcPts val="0"/>
               </a:spcBef>
               <a:spcAft>
-                <a:spcPts val="1400"/>
+                <a:spcPts val="1300"/>
               </a:spcAft>
             </a:pPr>
             <a:r>
-              <a:rPr sz="2600" b="0" i="0">
+              <a:rPr sz="2500" b="0" i="0">
                 <a:solidFill>
                   <a:srgbClr val="1E2F38"/>
                 </a:solidFill>
                 <a:latin typeface="Calibri"/>
               </a:rPr>
-              <a:t>• Uganda / Ministry of Health: Richer last-mile data into eCHIS and DHIS2; clearer referral closure; documented handoff p...</a:t>
+              <a:t>• Uganda / Ministry of Health: Richer last-mile data into eCHIS, DHIS2/eIDSR, and related national platforms; clearer referral...</a:t>
             </a:r>
           </a:p>
           <a:p>
@@ -5496,17 +5518,17 @@
                 <a:spcPts val="0"/>
               </a:spcBef>
               <a:spcAft>
-                <a:spcPts val="1400"/>
+                <a:spcPts val="1300"/>
               </a:spcAft>
             </a:pPr>
             <a:r>
-              <a:rPr sz="2600" b="0" i="0">
+              <a:rPr sz="2500" b="0" i="0">
                 <a:solidFill>
                   <a:srgbClr val="1E2F38"/>
                 </a:solidFill>
                 <a:latin typeface="Calibri"/>
               </a:rPr>
-              <a:t>• U.S. Department of State / GHSD: A Ugandan implementer with a live clinic and community network that protects essential ser...</a:t>
+              <a:t>• U.S. Department of State / GHSD: A Ugandan implementer with a live clinic and community network that protects essential services...</a:t>
             </a:r>
           </a:p>
           <a:p>
@@ -5518,17 +5540,39 @@
                 <a:spcPts val="0"/>
               </a:spcBef>
               <a:spcAft>
-                <a:spcPts val="1400"/>
+                <a:spcPts val="1300"/>
               </a:spcAft>
             </a:pPr>
             <a:r>
-              <a:rPr sz="2600" b="0" i="0">
+              <a:rPr sz="2500" b="0" i="0">
                 <a:solidFill>
                   <a:srgbClr val="1E2F38"/>
                 </a:solidFill>
                 <a:latin typeface="Calibri"/>
               </a:rPr>
-              <a:t>• Districts &amp; facilities: Dashboards for outreach targeting, referral follow-up, and programme monitoring; GIS hotsp...</a:t>
+              <a:t>• Districts &amp; facilities: Dashboards for outreach targeting, referral follow-up, and programme monitoring; GIS hotspot vi...</a:t>
+            </a:r>
+          </a:p>
+          <a:p>
+            <a:pPr algn="l">
+              <a:lnSpc>
+                <a:spcPct val="128000"/>
+              </a:lnSpc>
+              <a:spcBef>
+                <a:spcPts val="0"/>
+              </a:spcBef>
+              <a:spcAft>
+                <a:spcPts val="1300"/>
+              </a:spcAft>
+            </a:pPr>
+            <a:r>
+              <a:rPr sz="2500" b="0" i="0">
+                <a:solidFill>
+                  <a:srgbClr val="1E2F38"/>
+                </a:solidFill>
+                <a:latin typeface="Calibri"/>
+              </a:rPr>
+              <a:t>• Communities &amp; CHWs/VHTs: Simple offline tools, faster support from the medical centre, and care that reaches mothers, ch...</a:t>
             </a:r>
           </a:p>
           <a:p>
@@ -5544,13 +5588,13 @@
               </a:spcAft>
             </a:pPr>
             <a:r>
-              <a:rPr sz="2600" b="0" i="0">
+              <a:rPr sz="2500" b="0" i="0">
                 <a:solidFill>
                   <a:srgbClr val="1E2F38"/>
                 </a:solidFill>
                 <a:latin typeface="Calibri"/>
               </a:rPr>
-              <a:t>• Communities &amp; CHWs/VHTs: Simple offline tools, faster support from the medical centre, and care that reaches mother...</a:t>
+              <a:t>• FairBanks / FCHIP: Room to refine and document a production-grade interoperability model inside a real catchment -...</a:t>
             </a:r>
           </a:p>
         </p:txBody>
@@ -5924,7 +5968,7 @@
                 </a:solidFill>
                 <a:latin typeface="Calibri"/>
               </a:rPr>
-              <a:t>Proposed Objectives</a:t>
+              <a:t>Core Activities</a:t>
             </a:r>
           </a:p>
         </p:txBody>
@@ -5993,7 +6037,7 @@
                 </a:solidFill>
                 <a:latin typeface="Calibri"/>
               </a:rPr>
-              <a:t>• O1. Deploy offline-capable CHW/VHT capture aligned with eCHIS household and visit concepts across FairBanks Co...</a:t>
+              <a:t>• A1. Deploy offline-capable CHW/VHT capture aligned with eCHIS household and visit concepts across FairBanks Communi...</a:t>
             </a:r>
           </a:p>
           <a:p>
@@ -6015,7 +6059,7 @@
                 </a:solidFill>
                 <a:latin typeface="Calibri"/>
               </a:rPr>
-              <a:t>• O2. Establish a secure sync and role-based access pipeline linking community records to FairBanks Medical Cent...</a:t>
+              <a:t>• A2. Establish a secure sync and role-based access pipeline linking community records to FairBanks Medical Centre wo...</a:t>
             </a:r>
           </a:p>
           <a:p>
@@ -6037,7 +6081,7 @@
                 </a:solidFill>
                 <a:latin typeface="Calibri"/>
               </a:rPr>
-              <a:t>• O3. Map community indicators to DHIS2 reporting elements and demonstrate aggregate submission pathways for MNC...</a:t>
+              <a:t>• A3. Map community indicators to DHIS2 reporting elements and demonstrate aggregate submission pathways for MNCH, im...</a:t>
             </a:r>
           </a:p>
           <a:p>
@@ -6059,7 +6103,7 @@
                 </a:solidFill>
                 <a:latin typeface="Calibri"/>
               </a:rPr>
-              <a:t>• O4. Deliver facility and programme dashboards plus GIS hotspot views that trigger outreach, referrals, and sup...</a:t>
+              <a:t>• A4. Deliver facility and programme dashboards plus GIS hotspot views that trigger outreach, referrals, and supply p...</a:t>
             </a:r>
           </a:p>
         </p:txBody>
@@ -6502,7 +6546,7 @@
                 </a:solidFill>
                 <a:latin typeface="Calibri"/>
               </a:rPr>
-              <a:t>Cascade-rooted capture → secure sync → eCHIS/DHIS2/EMR interoperability → dashboards &amp; GIS → MoH-aligned transfer package.</a:t>
+              <a:t>Cascade-rooted capture → secure sync → eCHIS / EMR / DHIS2-eIDSR interoperability → dashboards &amp; GIS → MoH/NDHA-aligned transfer package.</a:t>
             </a:r>
           </a:p>
         </p:txBody>
@@ -6935,17 +6979,17 @@
                 <a:spcPts val="0"/>
               </a:spcBef>
               <a:spcAft>
-                <a:spcPts val="1100"/>
+                <a:spcPts val="1000"/>
               </a:spcAft>
             </a:pPr>
             <a:r>
-              <a:rPr sz="2000" b="0" i="0">
+              <a:rPr sz="1600" b="0" i="0">
                 <a:solidFill>
                   <a:srgbClr val="1E2F38"/>
                 </a:solidFill>
                 <a:latin typeface="Calibri"/>
               </a:rPr>
-              <a:t>• Digital completeness — Increase structured community visit capture flowing into facility and aggregate </a:t>
+              <a:t>• Save lives — Earlier alerts for missed ANC, immunisation gaps, fever clusters, and referral drop-o</a:t>
             </a:r>
           </a:p>
           <a:p>
@@ -6957,17 +7001,17 @@
                 <a:spcPts val="0"/>
               </a:spcBef>
               <a:spcAft>
-                <a:spcPts val="1100"/>
+                <a:spcPts val="1000"/>
               </a:spcAft>
             </a:pPr>
             <a:r>
-              <a:rPr sz="2000" b="0" i="0">
+              <a:rPr sz="1600" b="0" i="0">
                 <a:solidFill>
                   <a:srgbClr val="1E2F38"/>
                 </a:solidFill>
                 <a:latin typeface="Calibri"/>
               </a:rPr>
-              <a:t>• Interoperability proof — Working mappings and demo exports for eCHIS-aligned records and DHIS2 aggregates</a:t>
+              <a:t>• Strengthen systems — Working mappings and demo exports for eCHIS-aligned records and DHIS2/eIDSR aggregate</a:t>
             </a:r>
           </a:p>
           <a:p>
@@ -6979,17 +7023,39 @@
                 <a:spcPts val="0"/>
               </a:spcBef>
               <a:spcAft>
-                <a:spcPts val="1100"/>
+                <a:spcPts val="1000"/>
               </a:spcAft>
             </a:pPr>
             <a:r>
-              <a:rPr sz="2000" b="0" i="0">
+              <a:rPr sz="1600" b="0" i="0">
                 <a:solidFill>
                   <a:srgbClr val="1E2F38"/>
                 </a:solidFill>
                 <a:latin typeface="Calibri"/>
               </a:rPr>
-              <a:t>• Service continuity signals — Earlier alerts for missed ANC, immunisation gaps, fever clusters, and referral d</a:t>
+              <a:t>• Enhance efficiency — Less double entry and paper lag; role-based dashboards that shorten the path from com</a:t>
+            </a:r>
+          </a:p>
+          <a:p>
+            <a:pPr algn="l">
+              <a:lnSpc>
+                <a:spcPct val="128000"/>
+              </a:lnSpc>
+              <a:spcBef>
+                <a:spcPts val="0"/>
+              </a:spcBef>
+              <a:spcAft>
+                <a:spcPts val="1000"/>
+              </a:spcAft>
+            </a:pPr>
+            <a:r>
+              <a:rPr sz="1600" b="0" i="0">
+                <a:solidFill>
+                  <a:srgbClr val="1E2F38"/>
+                </a:solidFill>
+                <a:latin typeface="Calibri"/>
+              </a:rPr>
+              <a:t>• Foster self-reliance — Handoff package: source documentation, SOPs, training, hosting options, and a costed </a:t>
             </a:r>
           </a:p>
           <a:p>
@@ -7005,13 +7071,13 @@
               </a:spcAft>
             </a:pPr>
             <a:r>
-              <a:rPr sz="2000" b="0" i="0">
+              <a:rPr sz="1600" b="0" i="0">
                 <a:solidFill>
                   <a:srgbClr val="1E2F38"/>
                 </a:solidFill>
                 <a:latin typeface="Calibri"/>
               </a:rPr>
-              <a:t>• Accountability — Role-based audit trails, data-quality checks, and programme dashboards usable fo</a:t>
+              <a:t>• Advance U.S. interest — Measurable contribution to MOU digital transition: interoperable last-mile data under</a:t>
             </a:r>
           </a:p>
         </p:txBody>
@@ -7963,7 +8029,7 @@
                 </a:solidFill>
                 <a:latin typeface="Calibri"/>
               </a:rPr>
-              <a:t>eCHIS household capture → DHIS2 aggregates → facility EMR referrals → national warehouse readiness. Bridge layer — not a replacement silo.</a:t>
+              <a:t>eCHIS household capture → facility EMR (eAfya/ClinicMaster) → DHIS2/eIDSR → National Data Warehouse readiness → iHRIS-aware workforce. Bridge layer — not a replacement silo. Aligned with NDHA / OpenHIE.</a:t>
             </a:r>
           </a:p>
         </p:txBody>

</xml_diff>

<commit_message>
Update build_dos-uganda_docs.py and associated documents to reflect revised project title and narrative content for the Uganda Health System MOU (DFOP0017890). Enhance clarity and consistency across Word, PDF, and PowerPoint formats by streamlining language and ensuring alignment with new objectives focused on interoperability and government ownership. Adjust cost share descriptions and improve overall document coherence.
</commit_message>
<xml_diff>
--- a/applications/dos-uganda/documents/dos-uganda_ppt.pptx
+++ b/applications/dos-uganda/documents/dos-uganda_ppt.pptx
@@ -3340,7 +3340,7 @@
                 </a:solidFill>
                 <a:latin typeface="Calibri"/>
               </a:rPr>
-              <a:t>Objective 4 — Last-mile bridge into eCHIS, EMR, DHIS2/eIDSR, and NDHA</a:t>
+              <a:t>Objective 4 — Helping community visit data reach eCHIS, clinic records, and DHIS2/eIDSR</a:t>
             </a:r>
           </a:p>
         </p:txBody>
@@ -3385,7 +3385,7 @@
                 </a:solidFill>
                 <a:latin typeface="Calibri"/>
               </a:rPr>
-              <a:t>Win-win Phase 1 SOI  |  $1,850,000  |  36 months  |  Due 31 July 2026</a:t>
+              <a:t>Phase 1 Statement of Interest  |  $1,850,000  |  36 months  |  Due 31 July 2026</a:t>
             </a:r>
           </a:p>
         </p:txBody>
@@ -3671,7 +3671,7 @@
                 </a:solidFill>
                 <a:latin typeface="Calibri"/>
               </a:rPr>
-              <a:t>Sustainability &amp; Ownership</a:t>
+              <a:t>Ownership Over Time</a:t>
             </a:r>
           </a:p>
         </p:txBody>
@@ -3716,7 +3716,7 @@
                 </a:solidFill>
                 <a:latin typeface="Calibri"/>
               </a:rPr>
-              <a:t>Documented transition of staffing and recurrent costs toward GOU ownership by project close.</a:t>
+              <a:t>By project close, write down how staff roles and running costs move to government ownership.</a:t>
             </a:r>
           </a:p>
           <a:p>
@@ -3738,7 +3738,7 @@
                 </a:solidFill>
                 <a:latin typeface="Calibri"/>
               </a:rPr>
-              <a:t>Train Ugandan developers, CHW supervisors, and data stewards.</a:t>
+              <a:t>Train Ugandan developers, CHW supervisors, and data staff.</a:t>
             </a:r>
           </a:p>
           <a:p>
@@ -3760,7 +3760,7 @@
                 </a:solidFill>
                 <a:latin typeface="Calibri"/>
               </a:rPr>
-              <a:t>Clinic and outreach continue as FairBanks operations — the grant accelerates interoperable intelligence and transfer.</a:t>
+              <a:t>The clinic and outreach keep running as FairBanks work. The grant helps connect the data and prepare the handoff.</a:t>
             </a:r>
           </a:p>
         </p:txBody>
@@ -4134,7 +4134,7 @@
                 </a:solidFill>
                 <a:latin typeface="Calibri"/>
               </a:rPr>
-              <a:t>Readiness for Phase 2</a:t>
+              <a:t>Ready for Phase 2</a:t>
             </a:r>
           </a:p>
         </p:txBody>
@@ -4179,7 +4179,7 @@
                 </a:solidFill>
                 <a:latin typeface="Calibri"/>
               </a:rPr>
-              <a:t>This Statement of Interest confirms FairBanks' intent to advance Track 2, Objective 4 with a community-rooted, interoperable, government-aligned digital health proposal. We seek invitation to Phase 2 (full proposal) and/or consultative program design, where we will detail workplans, budgets, M&amp;E, partnership letters, and a clear transition of staffing and recurrent costs toward sustainable Ugandan ownership.</a:t>
+              <a:t>With this Statement of Interest, FairBanks asks to move Track 2, Objective 4 forward through a digital health approach rooted in community work, built to connect with government systems, and designed for Ugandan ownership. We hope to be invited to Phase 2 (full proposal) or joint programme design, where we will set out workplans, budgets, monitoring, partner letters, and a clear plan to hand over staffing and running costs.</a:t>
             </a:r>
           </a:p>
         </p:txBody>
@@ -4622,7 +4622,7 @@
                 </a:solidFill>
                 <a:latin typeface="Calibri"/>
               </a:rPr>
-              <a:t>Uganda's five-year health transition (April 2026-December 2030) asks facilities, districts, and communities to keep HIV, TB, malaria, maternal and child health, immunisation, and outbreak services strong while shifting toward government-led, performance-based programming. That shift only works if decision-makers see what is happening at the last mile - not weeks later in paper registers.</a:t>
+              <a:t>Uganda is moving through a five-year health transition (April 2026 to December 2030). Clinics, districts, and communities must keep HIV, TB, malaria, maternal and child health, immunisation, and outbreak services running well while more work shifts to government-led programmes. That only works if leaders can see what is happening in communities in time to act - not weeks later from paper books.</a:t>
             </a:r>
           </a:p>
           <a:p>
@@ -4644,7 +4644,7 @@
                 </a:solidFill>
                 <a:latin typeface="Calibri"/>
               </a:rPr>
-              <a:t>Community Health Workers and Village Health Teams already walk households and refer patients. Too often their work never reaches eCHIS, facility EMRs, DHIS2/eIDSR, or the National Data Warehouse in a usable form. National digital systems then miss early fever clusters, missed antenatal visits, immunisation gaps, and stock pressure. The result is reactive care, weak accountability, and higher risk that transition gains reverse.</a:t>
+              <a:t>Community Health Workers and Village Health Teams already visit homes and send people for care. Too often, what they record never reaches eCHIS, clinic records, DHIS2/eIDSR, or the National Data Warehouse in a form people can use. Then national systems miss rising fever cases, missed antenatal visits, gaps in immunisation, and medicine pressure. Care stays reactive, follow-up is weak, and hard-won gains can slip.</a:t>
             </a:r>
           </a:p>
         </p:txBody>
@@ -5018,7 +5018,7 @@
                 </a:solidFill>
                 <a:latin typeface="Calibri"/>
               </a:rPr>
-              <a:t>Statement of Interest</a:t>
+              <a:t>What We Propose</a:t>
             </a:r>
           </a:p>
         </p:txBody>
@@ -5081,13 +5081,13 @@
               </a:spcAft>
             </a:pPr>
             <a:r>
-              <a:rPr sz="2000" b="0" i="0">
+              <a:rPr sz="2200" b="0" i="0">
                 <a:solidFill>
                   <a:srgbClr val="1E2F38"/>
                 </a:solidFill>
                 <a:latin typeface="Calibri"/>
               </a:rPr>
-              <a:t>We propose to pilot and then transfer a community-to-facility intelligence layer - the FairBanks Community Health Intelligence Platform (FCHIP) - that captures CHW/VHT household and visit data offline, syncs securely, maps indicators to national reporting elements, and feeds facility and district action. FCHIP is not a parallel national system. It is a bridge that makes Uganda's existing digital stack more complete at community level and more useful for prevention.</a:t>
+              <a:t>We want to trial, then hand over, a practical tool - the FairBanks Community Health Intelligence Platform (FCHIP) - that lets CHWs and VHTs record household and visit information on phones even offline, sync it safely, match it to national reporting needs, and help the clinic and district act. FCHIP is not meant to replace Uganda's national systems. It is a bridge so community work shows up where it should and helps prevent problems earlier.</a:t>
             </a:r>
           </a:p>
         </p:txBody>
@@ -5461,7 +5461,7 @@
                 </a:solidFill>
                 <a:latin typeface="Calibri"/>
               </a:rPr>
-              <a:t>Win-Win Value</a:t>
+              <a:t>Who Gains What</a:t>
             </a:r>
           </a:p>
         </p:txBody>
@@ -5506,7 +5506,7 @@
                 </a:solidFill>
                 <a:latin typeface="Calibri"/>
               </a:rPr>
-              <a:t>• Uganda / Ministry of Health: Richer last-mile data into eCHIS, DHIS2/eIDSR, and related national platforms; clearer referral...</a:t>
+              <a:t>• Uganda / Ministry of Health: More complete community data in eCHIS, DHIS2/eIDSR, and related national systems; clearer proof...</a:t>
             </a:r>
           </a:p>
           <a:p>
@@ -5528,7 +5528,7 @@
                 </a:solidFill>
                 <a:latin typeface="Calibri"/>
               </a:rPr>
-              <a:t>• U.S. Department of State / GHSD: A Ugandan implementer with a live clinic and community network that protects essential services...</a:t>
+              <a:t>• U.S. Department of State / GHSD: A Ugandan partner with a working clinic and community network that keeps essential services goi...</a:t>
             </a:r>
           </a:p>
           <a:p>
@@ -5550,7 +5550,7 @@
                 </a:solidFill>
                 <a:latin typeface="Calibri"/>
               </a:rPr>
-              <a:t>• Districts &amp; facilities: Dashboards for outreach targeting, referral follow-up, and programme monitoring; GIS hotspot vi...</a:t>
+              <a:t>• Districts &amp; facilities: Simple screens to plan outreach, follow referrals, and track programmes; maps that show hotspot...</a:t>
             </a:r>
           </a:p>
           <a:p>
@@ -5572,7 +5572,7 @@
                 </a:solidFill>
                 <a:latin typeface="Calibri"/>
               </a:rPr>
-              <a:t>• Communities &amp; CHWs/VHTs: Simple offline tools, faster support from the medical centre, and care that reaches mothers, ch...</a:t>
+              <a:t>• Communities &amp; CHWs/VHTs: Easy tools that work offline, quicker support from the medical centre, and care that reaches mo...</a:t>
             </a:r>
           </a:p>
           <a:p>
@@ -5594,7 +5594,7 @@
                 </a:solidFill>
                 <a:latin typeface="Calibri"/>
               </a:rPr>
-              <a:t>• FairBanks / FCHIP: Room to refine and document a production-grade interoperability model inside a real catchment -...</a:t>
+              <a:t>• FairBanks / FCHIP: A real place to test and write down a working data-sharing approach, then share the guides, tra...</a:t>
             </a:r>
           </a:p>
         </p:txBody>
@@ -5968,7 +5968,7 @@
                 </a:solidFill>
                 <a:latin typeface="Calibri"/>
               </a:rPr>
-              <a:t>Core Activities</a:t>
+              <a:t>What We Will Do</a:t>
             </a:r>
           </a:p>
         </p:txBody>
@@ -6037,7 +6037,7 @@
                 </a:solidFill>
                 <a:latin typeface="Calibri"/>
               </a:rPr>
-              <a:t>• A1. Deploy offline-capable CHW/VHT capture aligned with eCHIS household and visit concepts across FairBanks Communi...</a:t>
+              <a:t>• A1. Put simple offline phone tools in the hands of CHWs and VHTs so household and visit records match eCHIS ideas a...</a:t>
             </a:r>
           </a:p>
           <a:p>
@@ -6059,7 +6059,7 @@
                 </a:solidFill>
                 <a:latin typeface="Calibri"/>
               </a:rPr>
-              <a:t>• A2. Establish a secure sync and role-based access pipeline linking community records to FairBanks Medical Centre wo...</a:t>
+              <a:t>• A2. Set up safe syncing and clear access rules so community records reach FairBanks Medical Centre work and authori...</a:t>
             </a:r>
           </a:p>
           <a:p>
@@ -6081,7 +6081,7 @@
                 </a:solidFill>
                 <a:latin typeface="Calibri"/>
               </a:rPr>
-              <a:t>• A3. Map community indicators to DHIS2 reporting elements and demonstrate aggregate submission pathways for MNCH, im...</a:t>
+              <a:t>• A3. Match community indicators to DHIS2 reports and show how summary data can move for maternal and child health, i...</a:t>
             </a:r>
           </a:p>
           <a:p>
@@ -6103,7 +6103,7 @@
                 </a:solidFill>
                 <a:latin typeface="Calibri"/>
               </a:rPr>
-              <a:t>• A4. Deliver facility and programme dashboards plus GIS hotspot views that trigger outreach, referrals, and supply p...</a:t>
+              <a:t>• A4. Give clinics and programmes clear dashboards and hotspot maps that help trigger outreach, referrals, and supply...</a:t>
             </a:r>
           </a:p>
         </p:txBody>
@@ -6477,7 +6477,7 @@
                 </a:solidFill>
                 <a:latin typeface="Calibri"/>
               </a:rPr>
-              <a:t>Project Approach</a:t>
+              <a:t>How We Will Work</a:t>
             </a:r>
           </a:p>
         </p:txBody>
@@ -6546,7 +6546,7 @@
                 </a:solidFill>
                 <a:latin typeface="Calibri"/>
               </a:rPr>
-              <a:t>Cascade-rooted capture → secure sync → eCHIS / EMR / DHIS2-eIDSR interoperability → dashboards &amp; GIS → MoH/NDHA-aligned transfer package.</a:t>
+              <a:t>Community visits → safe sync → links to eCHIS, clinic records, and DHIS2/eIDSR → dashboards and maps → clear handoff plan for the Ministry of Health.</a:t>
             </a:r>
           </a:p>
         </p:txBody>
@@ -6920,7 +6920,7 @@
                 </a:solidFill>
                 <a:latin typeface="Calibri"/>
               </a:rPr>
-              <a:t>Expected Outcomes</a:t>
+              <a:t>What Success Looks Like</a:t>
             </a:r>
           </a:p>
         </p:txBody>
@@ -6989,7 +6989,7 @@
                 </a:solidFill>
                 <a:latin typeface="Calibri"/>
               </a:rPr>
-              <a:t>• Save lives — Earlier alerts for missed ANC, immunisation gaps, fever clusters, and referral drop-o</a:t>
+              <a:t>• Save lives — Earlier notice of missed antenatal visits, immunisation gaps, fever clusters, and los</a:t>
             </a:r>
           </a:p>
           <a:p>
@@ -7011,7 +7011,7 @@
                 </a:solidFill>
                 <a:latin typeface="Calibri"/>
               </a:rPr>
-              <a:t>• Strengthen systems — Working mappings and demo exports for eCHIS-aligned records and DHIS2/eIDSR aggregate</a:t>
+              <a:t>• Strengthen systems — Working links and sample exports for eCHIS-style records and DHIS2/eIDSR summaries, w</a:t>
             </a:r>
           </a:p>
           <a:p>
@@ -7033,7 +7033,7 @@
                 </a:solidFill>
                 <a:latin typeface="Calibri"/>
               </a:rPr>
-              <a:t>• Enhance efficiency — Less double entry and paper lag; role-based dashboards that shorten the path from com</a:t>
+              <a:t>• Work more efficiently — Less double entry and less waiting on paper; screens that help teams move from a comm</a:t>
             </a:r>
           </a:p>
           <a:p>
@@ -7055,7 +7055,7 @@
                 </a:solidFill>
                 <a:latin typeface="Calibri"/>
               </a:rPr>
-              <a:t>• Foster self-reliance — Handoff package: source documentation, SOPs, training, hosting options, and a costed </a:t>
+              <a:t>• Build self-reliance — A handoff package with guides, standard procedures, training, hosting options, and a </a:t>
             </a:r>
           </a:p>
           <a:p>
@@ -7077,7 +7077,7 @@
                 </a:solidFill>
                 <a:latin typeface="Calibri"/>
               </a:rPr>
-              <a:t>• Advance U.S. interest — Measurable contribution to MOU digital transition: interoperable last-mile data under</a:t>
+              <a:t>• Support U.S. interest — A clear contribution to the MOU digital shift: community data that connects under gov</a:t>
             </a:r>
           </a:p>
         </p:txBody>
@@ -7451,7 +7451,7 @@
                 </a:solidFill>
                 <a:latin typeface="Calibri"/>
               </a:rPr>
-              <a:t>Organizational Capacity</a:t>
+              <a:t>Our Capacity</a:t>
             </a:r>
           </a:p>
         </p:txBody>
@@ -7520,7 +7520,7 @@
                 </a:solidFill>
                 <a:latin typeface="Calibri"/>
               </a:rPr>
-              <a:t>• Ugandan social enterprise with a functioning medical centre - clinical care, diagnostics, pharmacy, and referral pathways already in daily use.</a:t>
+              <a:t>• We are a Ugandan organisation with a working medical centre - clinic care, tests, pharmacy, and referrals already running every day.</a:t>
             </a:r>
           </a:p>
           <a:p>
@@ -7542,7 +7542,7 @@
                 </a:solidFill>
                 <a:latin typeface="Calibri"/>
               </a:rPr>
-              <a:t>• Active FairBanks Community Reach programmes: maternal and child health, Gericare, chronic disease screening, school and corporate health outreach.</a:t>
+              <a:t>• FairBanks Community Reach is active in maternal and child health, Gericare, chronic disease screening, and school and workplace outreach.</a:t>
             </a:r>
           </a:p>
           <a:p>
@@ -7564,7 +7564,7 @@
                 </a:solidFill>
                 <a:latin typeface="Calibri"/>
               </a:rPr>
-              <a:t>• Established CHW/VHT relationships in Kampala-area communities named above - real users, not a greenfield pilot.</a:t>
+              <a:t>• We already work with CHWs and VHTs in the Kampala-area communities named above. This is not starting from zero.</a:t>
             </a:r>
           </a:p>
           <a:p>
@@ -7586,7 +7586,7 @@
                 </a:solidFill>
                 <a:latin typeface="Calibri"/>
               </a:rPr>
-              <a:t>• Digital health records foundation and pharmacy dispensing data already supporting facility operations.</a:t>
+              <a:t>• We already keep digital clinic records and pharmacy dispensing data that support day-to-day facility work.</a:t>
             </a:r>
           </a:p>
         </p:txBody>
@@ -7960,7 +7960,7 @@
                 </a:solidFill>
                 <a:latin typeface="Calibri"/>
               </a:rPr>
-              <a:t>Interoperability</a:t>
+              <a:t>How Systems Connect</a:t>
             </a:r>
           </a:p>
         </p:txBody>
@@ -8029,7 +8029,7 @@
                 </a:solidFill>
                 <a:latin typeface="Calibri"/>
               </a:rPr>
-              <a:t>eCHIS household capture → facility EMR (eAfya/ClinicMaster) → DHIS2/eIDSR → National Data Warehouse readiness → iHRIS-aware workforce. Bridge layer — not a replacement silo. Aligned with NDHA / OpenHIE.</a:t>
+              <a:t>Phone tools for eCHIS-style household visits → clinic records (eAfya/ClinicMaster) → DHIS2/eIDSR summaries → National Data Warehouse when ready → CHW/VHT lists that can align with iHRIS. A bridge — not a replacement. Built to follow NDHA / OpenHIE sharing rules.</a:t>
             </a:r>
           </a:p>
         </p:txBody>

</xml_diff>

<commit_message>
Enhance documentation and code for FairBanks Community Health Intelligence Platform (FCHIP)
- Updated `build_dos-uganda_docs.py` to clarify the role of FCHIP in complementing Uganda's national health systems and ensuring data flows into the National Digital Health Architecture (NDHA).
- Revised project documents to reflect a documented transition plan for staffing and recurrent costs to the Ministry of Health by project close.
- Improved clarity in the proposed activities and outcomes, emphasizing collaboration with existing systems and partners.
- Adjusted the presentation of community health data benefits for stakeholders, ensuring alignment with U.S. health security goals.
</commit_message>
<xml_diff>
--- a/applications/dos-uganda/documents/dos-uganda_ppt.pptx
+++ b/applications/dos-uganda/documents/dos-uganda_ppt.pptx
@@ -3340,7 +3340,7 @@
                 </a:solidFill>
                 <a:latin typeface="Calibri"/>
               </a:rPr>
-              <a:t>Objective 4 — Helping community visit data reach eCHIS, clinic records, and DHIS2/eIDSR</a:t>
+              <a:t>Objective 4 - Helping community visit data reach eCHIS, clinic records, and DHIS2/eIDSR</a:t>
             </a:r>
           </a:p>
         </p:txBody>
@@ -5025,7 +5025,7 @@
       </p:sp>
       <p:pic>
         <p:nvPicPr>
-          <p:cNvPr id="5" name="Picture 4" descr="data_flow_iso_labeled_opt.jpg"/>
+          <p:cNvPr id="5" name="Picture 4" descr="data_flow_iso_labeled_opt_fchip.jpg"/>
           <p:cNvPicPr>
             <a:picLocks noChangeAspect="1"/>
           </p:cNvPicPr>
@@ -5039,8 +5039,8 @@
         </p:blipFill>
         <p:spPr>
           <a:xfrm>
-            <a:off x="411480" y="1890391"/>
-            <a:ext cx="5303520" cy="3534417"/>
+            <a:off x="411480" y="1889760"/>
+            <a:ext cx="5303520" cy="3535680"/>
           </a:xfrm>
           <a:prstGeom prst="rect">
             <a:avLst/>
@@ -5081,13 +5081,13 @@
               </a:spcAft>
             </a:pPr>
             <a:r>
-              <a:rPr sz="2200" b="0" i="0">
+              <a:rPr sz="1700" b="0" i="0">
                 <a:solidFill>
                   <a:srgbClr val="1E2F38"/>
                 </a:solidFill>
                 <a:latin typeface="Calibri"/>
               </a:rPr>
-              <a:t>We want to trial, then hand over, a practical tool - the FairBanks Community Health Intelligence Platform (FCHIP) - that lets CHWs and VHTs record household and visit information on phones even offline, sync it safely, match it to national reporting needs, and help the clinic and district act. FCHIP is not meant to replace Uganda's national systems. It is a bridge so community work shows up where it should and helps prevent problems earlier.</a:t>
+              <a:t>We want to trial, then hand over, a practical tool - the FairBanks Community Health Intelligence Platform (FCHIP) - that lets CHWs and VHTs record household and visit information on phones even offline, sync it safely, match it to national reporting needs, and help the clinic and district act. FCHIP is not meant to replace Uganda's national systems or duplicate existing U.S.-supported digital health work. It is a complementary bridge so community work shows up where it should and helps prevent problems earlier - without creating a parallel silo.</a:t>
             </a:r>
           </a:p>
         </p:txBody>
@@ -7055,7 +7055,7 @@
                 </a:solidFill>
                 <a:latin typeface="Calibri"/>
               </a:rPr>
-              <a:t>• Build self-reliance — A handoff package with guides, standard procedures, training, hosting options, and a </a:t>
+              <a:t>• Build self-reliance — Documented transition of staffing and recurrent operating costs to the Ministry of He</a:t>
             </a:r>
           </a:p>
           <a:p>

</xml_diff>